<commit_message>
Finalize Phase 4 policy analysis: add realistic policy-path charts with decline + uncertainty bands, implement robust regional handling with diagnostics fallback, include policy mechanism table, relative impact analysis, and polished conclusion markdown
</commit_message>
<xml_diff>
--- a/project_reports/10APR_Progress copy.pptx
+++ b/project_reports/10APR_Progress copy.pptx
@@ -1893,7 +1893,7 @@
               <a:t>LightGBM</a:t>
             </a:r>
             <a:r>
-              <a:rPr lang="en-US"/>
+              <a:rPr lang="en-US" dirty="0"/>
               <a:t> might achieve slightly higher accuracy if your data is very clean and you have the computational time to fine-tune hyperparameters.</a:t>
             </a:r>
           </a:p>
@@ -1907,7 +1907,7 @@
               </a:spcAft>
               <a:buNone/>
             </a:pPr>
-            <a:endParaRPr lang="en-US"/>
+            <a:endParaRPr lang="en-US" dirty="0"/>
           </a:p>
           <a:p>
             <a:pPr marL="0" lvl="0" indent="0" algn="l" rtl="0">
@@ -23073,6 +23073,15 @@
 </file>
 
 <file path=customXml/item1.xml><?xml version="1.0" encoding="utf-8"?>
+<?mso-contentType ?>
+<FormTemplates xmlns="http://schemas.microsoft.com/sharepoint/v3/contenttype/forms">
+  <Display>DocumentLibraryForm</Display>
+  <Edit>DocumentLibraryForm</Edit>
+  <New>DocumentLibraryForm</New>
+</FormTemplates>
+</file>
+
+<file path=customXml/item2.xml><?xml version="1.0" encoding="utf-8"?>
 <p:properties xmlns:p="http://schemas.microsoft.com/office/2006/metadata/properties" xmlns:xsi="http://www.w3.org/2001/XMLSchema-instance" xmlns:pc="http://schemas.microsoft.com/office/infopath/2007/PartnerControls">
   <documentManagement>
     <_activity xmlns="11e45801-bee2-4eee-abb6-7fc01a896634" xsi:nil="true"/>
@@ -23080,7 +23089,7 @@
 </p:properties>
 </file>
 
-<file path=customXml/item2.xml><?xml version="1.0" encoding="utf-8"?>
+<file path=customXml/item3.xml><?xml version="1.0" encoding="utf-8"?>
 <ct:contentTypeSchema xmlns:ct="http://schemas.microsoft.com/office/2006/metadata/contentType" xmlns:ma="http://schemas.microsoft.com/office/2006/metadata/properties/metaAttributes" ct:_="" ma:_="" ma:contentTypeName="Document" ma:contentTypeID="0x01010015021A5DC4BEF54E90B3A7E0D30B82FD" ma:contentTypeVersion="5" ma:contentTypeDescription="Create a new document." ma:contentTypeScope="" ma:versionID="0b09cb170d6a15113edb6f479f6ecd10">
   <xsd:schema xmlns:xsd="http://www.w3.org/2001/XMLSchema" xmlns:xs="http://www.w3.org/2001/XMLSchema" xmlns:p="http://schemas.microsoft.com/office/2006/metadata/properties" xmlns:ns3="11e45801-bee2-4eee-abb6-7fc01a896634" targetNamespace="http://schemas.microsoft.com/office/2006/metadata/properties" ma:root="true" ma:fieldsID="c9b1b393770a16940206f9bb69539431" ns3:_="">
     <xsd:import namespace="11e45801-bee2-4eee-abb6-7fc01a896634"/>
@@ -23230,16 +23239,15 @@
 </ct:contentTypeSchema>
 </file>
 
-<file path=customXml/item3.xml><?xml version="1.0" encoding="utf-8"?>
-<?mso-contentType ?>
-<FormTemplates xmlns="http://schemas.microsoft.com/sharepoint/v3/contenttype/forms">
-  <Display>DocumentLibraryForm</Display>
-  <Edit>DocumentLibraryForm</Edit>
-  <New>DocumentLibraryForm</New>
-</FormTemplates>
+<file path=customXml/itemProps1.xml><?xml version="1.0" encoding="utf-8"?>
+<ds:datastoreItem xmlns:ds="http://schemas.openxmlformats.org/officeDocument/2006/customXml" ds:itemID="{B94EBF72-05B3-4092-B058-100DE54983B2}">
+  <ds:schemaRefs>
+    <ds:schemaRef ds:uri="http://schemas.microsoft.com/sharepoint/v3/contenttype/forms"/>
+  </ds:schemaRefs>
+</ds:datastoreItem>
 </file>
 
-<file path=customXml/itemProps1.xml><?xml version="1.0" encoding="utf-8"?>
+<file path=customXml/itemProps2.xml><?xml version="1.0" encoding="utf-8"?>
 <ds:datastoreItem xmlns:ds="http://schemas.openxmlformats.org/officeDocument/2006/customXml" ds:itemID="{1EFFF01E-6DF4-4530-B663-FF4BD91444A6}">
   <ds:schemaRefs>
     <ds:schemaRef ds:uri="11e45801-bee2-4eee-abb6-7fc01a896634"/>
@@ -23255,7 +23263,7 @@
 </ds:datastoreItem>
 </file>
 
-<file path=customXml/itemProps2.xml><?xml version="1.0" encoding="utf-8"?>
+<file path=customXml/itemProps3.xml><?xml version="1.0" encoding="utf-8"?>
 <ds:datastoreItem xmlns:ds="http://schemas.openxmlformats.org/officeDocument/2006/customXml" ds:itemID="{CB7AAD6B-2CD1-4FD9-A228-72630DF2E75E}">
   <ds:schemaRefs>
     <ds:schemaRef ds:uri="http://schemas.microsoft.com/office/2006/metadata/contentType"/>
@@ -23271,12 +23279,4 @@
     <ds:schemaRef ds:uri="http://schemas.microsoft.com/internal/obd"/>
   </ds:schemaRefs>
 </ds:datastoreItem>
-</file>
-
-<file path=customXml/itemProps3.xml><?xml version="1.0" encoding="utf-8"?>
-<ds:datastoreItem xmlns:ds="http://schemas.openxmlformats.org/officeDocument/2006/customXml" ds:itemID="{B94EBF72-05B3-4092-B058-100DE54983B2}">
-  <ds:schemaRefs>
-    <ds:schemaRef ds:uri="http://schemas.microsoft.com/sharepoint/v3/contenttype/forms"/>
-  </ds:schemaRefs>
-</ds:datastoreItem>
 </file>
</xml_diff>